<commit_message>
Update for NET 8.0
</commit_message>
<xml_diff>
--- a/documentation/Presentation 2 - distributed linear algebra.pptx
+++ b/documentation/Presentation 2 - distributed linear algebra.pptx
@@ -254,7 +254,7 @@
           <a:p>
             <a:fld id="{AEC64D6E-F2A5-42B4-A03E-33B645EC2152}" type="datetimeFigureOut">
               <a:rPr lang="en-US" smtClean="0"/>
-              <a:t>14-May-20</a:t>
+              <a:t>17-Oct-26</a:t>
             </a:fld>
             <a:endParaRPr lang="en-US"/>
           </a:p>
@@ -431,7 +431,7 @@
           <a:p>
             <a:fld id="{98E622A7-7F18-4496-99E7-6AA62B4CF0EC}" type="datetimeFigureOut">
               <a:rPr lang="en-US" smtClean="0"/>
-              <a:t>14-May-20</a:t>
+              <a:t>17-Oct-26</a:t>
             </a:fld>
             <a:endParaRPr lang="en-US"/>
           </a:p>
@@ -1364,7 +1364,7 @@
         <p:spPr>
           <a:xfrm>
             <a:off x="9848674" y="6431727"/>
-            <a:ext cx="2255233" cy="400110"/>
+            <a:ext cx="2334422" cy="400110"/>
           </a:xfrm>
           <a:prstGeom prst="rect">
             <a:avLst/>
@@ -1393,13 +1393,7 @@
               <a:rPr lang="en-US" sz="2000" baseline="0" dirty="0" smtClean="0">
                 <a:latin typeface="+mn-lt"/>
               </a:rPr>
-              <a:t>15 </a:t>
-            </a:r>
-            <a:r>
-              <a:rPr lang="en-US" sz="2000" baseline="0" dirty="0">
-                <a:latin typeface="+mn-lt"/>
-              </a:rPr>
-              <a:t>May 2020</a:t>
+              <a:t>October 2026</a:t>
             </a:r>
             <a:endParaRPr lang="en-US" sz="2000" dirty="0">
               <a:latin typeface="+mn-lt"/>
@@ -6950,11 +6944,7 @@
           <a:p>
             <a:r>
               <a:rPr lang="en-US" dirty="0" smtClean="0"/>
-              <a:t>10</a:t>
-            </a:r>
-            <a:r>
-              <a:rPr lang="en-US" dirty="0" smtClean="0"/>
-              <a:t>/10</a:t>
+              <a:t>10/10</a:t>
             </a:r>
             <a:endParaRPr lang="en-US" dirty="0"/>
           </a:p>

</xml_diff>